<commit_message>
Correct human-recorded demo slide selection
</commit_message>
<xml_diff>
--- a/runs/live-20261010T142614Z-b7aaa14e/package/technical_demo/technical-demo-human-recording.pptx
+++ b/runs/live-20261010T142614Z-b7aaa14e/package/technical_demo/technical-demo-human-recording.pptx
@@ -7,9 +7,9 @@
   <p:sldIdLst>
     <p:sldId id="256" r:id="rId2"/>
     <p:sldId id="257" r:id="rId3"/>
-    <p:sldId id="259" r:id="rId5"/>
-    <p:sldId id="261" r:id="rId7"/>
-    <p:sldId id="263" r:id="rId9"/>
+    <p:sldId id="258" r:id="rId4"/>
+    <p:sldId id="260" r:id="rId6"/>
+    <p:sldId id="262" r:id="rId8"/>
   </p:sldIdLst>
   <p:notesMasterIdLst>
     <p:notesMasterId r:id="rId10"/>
@@ -636,7 +636,7 @@
 </p:notes>
 </file>
 
-<file path=ppt/notesSlides/notesSlide4.xml><?xml version="1.0" encoding="utf-8"?>
+<file path=ppt/notesSlides/notesSlide3.xml><?xml version="1.0" encoding="utf-8"?>
 <p:notes xmlns:a="http://schemas.openxmlformats.org/drawingml/2006/main" xmlns:r="http://schemas.openxmlformats.org/officeDocument/2006/relationships" xmlns:p="http://schemas.openxmlformats.org/presentationml/2006/main">
   <p:cSld>
     <p:spTree>
@@ -705,7 +705,7 @@
           <a:p>
             <a:fld id="{F7021451-1387-4CA6-816F-3879F97B5CBC}" type="slidenum">
               <a:rPr lang="en-US"/>
-              <a:t>4</a:t>
+              <a:t>3</a:t>
             </a:fld>
             <a:endParaRPr lang="en-US"/>
           </a:p>
@@ -724,7 +724,7 @@
 </p:notes>
 </file>
 
-<file path=ppt/notesSlides/notesSlide6.xml><?xml version="1.0" encoding="utf-8"?>
+<file path=ppt/notesSlides/notesSlide5.xml><?xml version="1.0" encoding="utf-8"?>
 <p:notes xmlns:a="http://schemas.openxmlformats.org/drawingml/2006/main" xmlns:r="http://schemas.openxmlformats.org/officeDocument/2006/relationships" xmlns:p="http://schemas.openxmlformats.org/presentationml/2006/main">
   <p:cSld>
     <p:spTree>
@@ -793,7 +793,7 @@
           <a:p>
             <a:fld id="{F7021451-1387-4CA6-816F-3879F97B5CBC}" type="slidenum">
               <a:rPr lang="en-US"/>
-              <a:t>6</a:t>
+              <a:t>5</a:t>
             </a:fld>
             <a:endParaRPr lang="en-US"/>
           </a:p>
@@ -812,7 +812,7 @@
 </p:notes>
 </file>
 
-<file path=ppt/notesSlides/notesSlide8.xml><?xml version="1.0" encoding="utf-8"?>
+<file path=ppt/notesSlides/notesSlide7.xml><?xml version="1.0" encoding="utf-8"?>
 <p:notes xmlns:a="http://schemas.openxmlformats.org/drawingml/2006/main" xmlns:r="http://schemas.openxmlformats.org/officeDocument/2006/relationships" xmlns:p="http://schemas.openxmlformats.org/presentationml/2006/main">
   <p:cSld>
     <p:spTree>
@@ -881,7 +881,7 @@
           <a:p>
             <a:fld id="{F7021451-1387-4CA6-816F-3879F97B5CBC}" type="slidenum">
               <a:rPr lang="en-US"/>
-              <a:t>8</a:t>
+              <a:t>7</a:t>
             </a:fld>
             <a:endParaRPr lang="en-US"/>
           </a:p>
@@ -3011,9 +3011,9 @@
 </p:sld>
 </file>
 
-<file path=ppt/slides/slide4.xml><?xml version="1.0" encoding="utf-8"?>
+<file path=ppt/slides/slide3.xml><?xml version="1.0" encoding="utf-8"?>
 <p:sld xmlns:a="http://schemas.openxmlformats.org/drawingml/2006/main" xmlns:r="http://schemas.openxmlformats.org/officeDocument/2006/relationships" xmlns:p="http://schemas.openxmlformats.org/presentationml/2006/main">
-  <p:cSld name="Slide 4">
+  <p:cSld name="Slide 3">
     <p:bg>
       <p:bgPr>
         <a:solidFill>
@@ -3113,7 +3113,7 @@
                 <a:ea typeface="Arial" pitchFamily="34" charset="-122"/>
                 <a:cs typeface="Arial" pitchFamily="34" charset="-120"/>
               </a:rPr>
-              <a:t>PUBLISHED-CLAIM TRACE</a:t>
+              <a:t>REPEATABILITY</a:t>
             </a:r>
             <a:endParaRPr lang="en-US" sz="1100" dirty="0"/>
           </a:p>
@@ -3185,7 +3185,7 @@
                 <a:ea typeface="Arial" pitchFamily="34" charset="-122"/>
                 <a:cs typeface="Arial" pitchFamily="34" charset="-120"/>
               </a:rPr>
-              <a:t>ONE SOURCE · EXACT EVIDENCE</a:t>
+              <a:t>TWO LIVE RUNS ON DIFFERENT DATES</a:t>
             </a:r>
             <a:endParaRPr lang="en-US" sz="1100" dirty="0"/>
           </a:p>
@@ -3230,7 +3230,7 @@
                 <a:ea typeface="Arial" pitchFamily="34" charset="-122"/>
                 <a:cs typeface="Arial" pitchFamily="34" charset="-120"/>
               </a:rPr>
-              <a:t>A qualitative perspective, not a performance result</a:t>
+              <a:t>Repeated observations do not become fake changes</a:t>
             </a:r>
             <a:endParaRPr lang="en-US" sz="2800" dirty="0"/>
           </a:p>
@@ -3244,12 +3244,12 @@
         </p:nvSpPr>
         <p:spPr>
           <a:xfrm>
-            <a:off x="533400" y="1854101"/>
-            <a:ext cx="3873401" cy="2463701"/>
+            <a:off x="533400" y="1917650"/>
+            <a:ext cx="3810000" cy="2120801"/>
           </a:xfrm>
           <a:prstGeom prst="roundRect">
             <a:avLst>
-              <a:gd name="adj" fmla="val 1031"/>
+              <a:gd name="adj" fmla="val 1198"/>
             </a:avLst>
           </a:prstGeom>
           <a:solidFill>
@@ -3280,8 +3280,8 @@
         </p:nvSpPr>
         <p:spPr>
           <a:xfrm>
-            <a:off x="822275" y="2117527"/>
-            <a:ext cx="3361563" cy="164902"/>
+            <a:off x="822275" y="2181076"/>
+            <a:ext cx="3296894" cy="164902"/>
           </a:xfrm>
           <a:prstGeom prst="rect">
             <a:avLst/>
@@ -3308,7 +3308,7 @@
                 <a:ea typeface="Arial" pitchFamily="34" charset="-122"/>
                 <a:cs typeface="Arial" pitchFamily="34" charset="-120"/>
               </a:rPr>
-              <a:t>STABLE EVIDENCE IDENTITY</a:t>
+              <a:t>OCTOBER 9 · AWAITING REVIEW</a:t>
             </a:r>
             <a:endParaRPr lang="en-US" sz="1100" dirty="0"/>
           </a:p>
@@ -3322,74 +3322,281 @@
         </p:nvSpPr>
         <p:spPr>
           <a:xfrm>
-            <a:off x="822275" y="2460129"/>
-            <a:ext cx="3361563" cy="269677"/>
-          </a:xfrm>
-          <a:prstGeom prst="rect">
-            <a:avLst/>
-          </a:prstGeom>
-          <a:noFill/>
-          <a:ln/>
-        </p:spPr>
-        <p:txBody>
-          <a:bodyPr wrap="square" lIns="0" tIns="0" rIns="0" bIns="0" rtlCol="0" anchor="t"/>
-          <a:lstStyle/>
-          <a:p>
-            <a:pPr algn="l" indent="0" marL="0">
-              <a:lnSpc>
-                <a:spcPts val="2124"/>
+            <a:off x="822275" y="2574578"/>
+            <a:ext cx="585966" cy="373261"/>
+          </a:xfrm>
+          <a:prstGeom prst="rect">
+            <a:avLst/>
+          </a:prstGeom>
+          <a:noFill/>
+          <a:ln/>
+        </p:spPr>
+        <p:txBody>
+          <a:bodyPr wrap="square" lIns="0" tIns="0" rIns="0" bIns="0" rtlCol="0" anchor="t"/>
+          <a:lstStyle/>
+          <a:p>
+            <a:pPr algn="l" indent="0" marL="0">
+              <a:lnSpc>
+                <a:spcPts val="2940"/>
+              </a:lnSpc>
+              <a:buNone/>
+            </a:pPr>
+            <a:r>
+              <a:rPr lang="en-US" sz="2800" b="1" dirty="0">
+                <a:solidFill>
+                  <a:srgbClr val="182433"/>
+                </a:solidFill>
+                <a:latin typeface="Arial" pitchFamily="34" charset="0"/>
+                <a:ea typeface="Arial" pitchFamily="34" charset="-122"/>
+                <a:cs typeface="Arial" pitchFamily="34" charset="-120"/>
+              </a:rPr>
+              <a:t>50</a:t>
+            </a:r>
+            <a:endParaRPr lang="en-US" sz="2800" dirty="0"/>
+          </a:p>
+        </p:txBody>
+      </p:sp>
+      <p:sp>
+        <p:nvSpPr>
+          <p:cNvPr id="10" name="Text 8"/>
+          <p:cNvSpPr/>
+          <p:nvPr/>
+        </p:nvSpPr>
+        <p:spPr>
+          <a:xfrm>
+            <a:off x="822275" y="2947839"/>
+            <a:ext cx="585966" cy="181570"/>
+          </a:xfrm>
+          <a:prstGeom prst="rect">
+            <a:avLst/>
+          </a:prstGeom>
+          <a:noFill/>
+          <a:ln/>
+        </p:spPr>
+        <p:txBody>
+          <a:bodyPr wrap="square" lIns="0" tIns="0" rIns="0" bIns="0" rtlCol="0" anchor="t"/>
+          <a:lstStyle/>
+          <a:p>
+            <a:pPr algn="l" indent="0" marL="0">
+              <a:lnSpc>
+                <a:spcPts val="1430"/>
+              </a:lnSpc>
+              <a:buNone/>
+            </a:pPr>
+            <a:r>
+              <a:rPr lang="en-US" sz="1100" dirty="0">
+                <a:solidFill>
+                  <a:srgbClr val="5D6870"/>
+                </a:solidFill>
+                <a:latin typeface="Arial" pitchFamily="34" charset="0"/>
+                <a:ea typeface="Arial" pitchFamily="34" charset="-122"/>
+                <a:cs typeface="Arial" pitchFamily="34" charset="-120"/>
+              </a:rPr>
+              <a:t>extracted</a:t>
+            </a:r>
+            <a:endParaRPr lang="en-US" sz="1100" dirty="0"/>
+          </a:p>
+        </p:txBody>
+      </p:sp>
+      <p:sp>
+        <p:nvSpPr>
+          <p:cNvPr id="11" name="Text 9"/>
+          <p:cNvSpPr/>
+          <p:nvPr/>
+        </p:nvSpPr>
+        <p:spPr>
+          <a:xfrm>
+            <a:off x="1777752" y="2574578"/>
+            <a:ext cx="261408" cy="373261"/>
+          </a:xfrm>
+          <a:prstGeom prst="rect">
+            <a:avLst/>
+          </a:prstGeom>
+          <a:noFill/>
+          <a:ln/>
+        </p:spPr>
+        <p:txBody>
+          <a:bodyPr wrap="square" lIns="0" tIns="0" rIns="0" bIns="0" rtlCol="0" anchor="t"/>
+          <a:lstStyle/>
+          <a:p>
+            <a:pPr algn="l" indent="0" marL="0">
+              <a:lnSpc>
+                <a:spcPts val="2940"/>
+              </a:lnSpc>
+              <a:buNone/>
+            </a:pPr>
+            <a:r>
+              <a:rPr lang="en-US" sz="2800" b="1" dirty="0">
+                <a:solidFill>
+                  <a:srgbClr val="182433"/>
+                </a:solidFill>
+                <a:latin typeface="Arial" pitchFamily="34" charset="0"/>
+                <a:ea typeface="Arial" pitchFamily="34" charset="-122"/>
+                <a:cs typeface="Arial" pitchFamily="34" charset="-120"/>
+              </a:rPr>
+              <a:t>3</a:t>
+            </a:r>
+            <a:endParaRPr lang="en-US" sz="2800" dirty="0"/>
+          </a:p>
+        </p:txBody>
+      </p:sp>
+      <p:sp>
+        <p:nvSpPr>
+          <p:cNvPr id="12" name="Text 10"/>
+          <p:cNvSpPr/>
+          <p:nvPr/>
+        </p:nvSpPr>
+        <p:spPr>
+          <a:xfrm>
+            <a:off x="1777752" y="2947839"/>
+            <a:ext cx="261408" cy="181570"/>
+          </a:xfrm>
+          <a:prstGeom prst="rect">
+            <a:avLst/>
+          </a:prstGeom>
+          <a:noFill/>
+          <a:ln/>
+        </p:spPr>
+        <p:txBody>
+          <a:bodyPr wrap="square" lIns="0" tIns="0" rIns="0" bIns="0" rtlCol="0" anchor="t"/>
+          <a:lstStyle/>
+          <a:p>
+            <a:pPr algn="l" indent="0" marL="0">
+              <a:lnSpc>
+                <a:spcPts val="1430"/>
+              </a:lnSpc>
+              <a:buNone/>
+            </a:pPr>
+            <a:r>
+              <a:rPr lang="en-US" sz="1100" dirty="0">
+                <a:solidFill>
+                  <a:srgbClr val="5D6870"/>
+                </a:solidFill>
+                <a:latin typeface="Arial" pitchFamily="34" charset="0"/>
+                <a:ea typeface="Arial" pitchFamily="34" charset="-122"/>
+                <a:cs typeface="Arial" pitchFamily="34" charset="-120"/>
+              </a:rPr>
+              <a:t>new</a:t>
+            </a:r>
+            <a:endParaRPr lang="en-US" sz="1100" dirty="0"/>
+          </a:p>
+        </p:txBody>
+      </p:sp>
+      <p:sp>
+        <p:nvSpPr>
+          <p:cNvPr id="13" name="Text 11"/>
+          <p:cNvSpPr/>
+          <p:nvPr/>
+        </p:nvSpPr>
+        <p:spPr>
+          <a:xfrm>
+            <a:off x="2415034" y="2574578"/>
+            <a:ext cx="704981" cy="373261"/>
+          </a:xfrm>
+          <a:prstGeom prst="rect">
+            <a:avLst/>
+          </a:prstGeom>
+          <a:noFill/>
+          <a:ln/>
+        </p:spPr>
+        <p:txBody>
+          <a:bodyPr wrap="square" lIns="0" tIns="0" rIns="0" bIns="0" rtlCol="0" anchor="t"/>
+          <a:lstStyle/>
+          <a:p>
+            <a:pPr algn="l" indent="0" marL="0">
+              <a:lnSpc>
+                <a:spcPts val="2940"/>
+              </a:lnSpc>
+              <a:buNone/>
+            </a:pPr>
+            <a:r>
+              <a:rPr lang="en-US" sz="2800" b="1" dirty="0">
+                <a:solidFill>
+                  <a:srgbClr val="182433"/>
+                </a:solidFill>
+                <a:latin typeface="Arial" pitchFamily="34" charset="0"/>
+                <a:ea typeface="Arial" pitchFamily="34" charset="-122"/>
+                <a:cs typeface="Arial" pitchFamily="34" charset="-120"/>
+              </a:rPr>
+              <a:t>47</a:t>
+            </a:r>
+            <a:endParaRPr lang="en-US" sz="2800" dirty="0"/>
+          </a:p>
+        </p:txBody>
+      </p:sp>
+      <p:sp>
+        <p:nvSpPr>
+          <p:cNvPr id="14" name="Text 12"/>
+          <p:cNvSpPr/>
+          <p:nvPr/>
+        </p:nvSpPr>
+        <p:spPr>
+          <a:xfrm>
+            <a:off x="2415034" y="2947839"/>
+            <a:ext cx="704981" cy="181570"/>
+          </a:xfrm>
+          <a:prstGeom prst="rect">
+            <a:avLst/>
+          </a:prstGeom>
+          <a:noFill/>
+          <a:ln/>
+        </p:spPr>
+        <p:txBody>
+          <a:bodyPr wrap="square" lIns="0" tIns="0" rIns="0" bIns="0" rtlCol="0" anchor="t"/>
+          <a:lstStyle/>
+          <a:p>
+            <a:pPr algn="l" indent="0" marL="0">
+              <a:lnSpc>
+                <a:spcPts val="1430"/>
+              </a:lnSpc>
+              <a:buNone/>
+            </a:pPr>
+            <a:r>
+              <a:rPr lang="en-US" sz="1100" dirty="0">
+                <a:solidFill>
+                  <a:srgbClr val="5D6870"/>
+                </a:solidFill>
+                <a:latin typeface="Arial" pitchFamily="34" charset="0"/>
+                <a:ea typeface="Arial" pitchFamily="34" charset="-122"/>
+                <a:cs typeface="Arial" pitchFamily="34" charset="-120"/>
+              </a:rPr>
+              <a:t>unchanged</a:t>
+            </a:r>
+            <a:endParaRPr lang="en-US" sz="1100" dirty="0"/>
+          </a:p>
+        </p:txBody>
+      </p:sp>
+      <p:sp>
+        <p:nvSpPr>
+          <p:cNvPr id="15" name="Text 13"/>
+          <p:cNvSpPr/>
+          <p:nvPr/>
+        </p:nvSpPr>
+        <p:spPr>
+          <a:xfrm>
+            <a:off x="822275" y="3332559"/>
+            <a:ext cx="3296894" cy="181570"/>
+          </a:xfrm>
+          <a:prstGeom prst="rect">
+            <a:avLst/>
+          </a:prstGeom>
+          <a:noFill/>
+          <a:ln/>
+        </p:spPr>
+        <p:txBody>
+          <a:bodyPr wrap="square" lIns="0" tIns="0" rIns="0" bIns="0" rtlCol="0" anchor="t"/>
+          <a:lstStyle/>
+          <a:p>
+            <a:pPr algn="l" indent="0" marL="0">
+              <a:lnSpc>
+                <a:spcPts val="1430"/>
               </a:lnSpc>
               <a:spcBef>
-                <a:spcPts val="1400"/>
+                <a:spcPts val="1600"/>
               </a:spcBef>
               <a:buNone/>
             </a:pPr>
             <a:r>
-              <a:rPr lang="en-US" sz="1800" b="1" dirty="0">
-                <a:solidFill>
-                  <a:srgbClr val="182433"/>
-                </a:solidFill>
-                <a:latin typeface="Arial" pitchFamily="34" charset="0"/>
-                <a:ea typeface="Arial" pitchFamily="34" charset="-122"/>
-                <a:cs typeface="Arial" pitchFamily="34" charset="-120"/>
-              </a:rPr>
-              <a:t>youtube:q_g-rU1kW2o</a:t>
-            </a:r>
-            <a:endParaRPr lang="en-US" sz="1800" dirty="0"/>
-          </a:p>
-        </p:txBody>
-      </p:sp>
-      <p:sp>
-        <p:nvSpPr>
-          <p:cNvPr id="10" name="Text 8"/>
-          <p:cNvSpPr/>
-          <p:nvPr/>
-        </p:nvSpPr>
-        <p:spPr>
-          <a:xfrm>
-            <a:off x="822275" y="2856756"/>
-            <a:ext cx="3361563" cy="363141"/>
-          </a:xfrm>
-          <a:prstGeom prst="rect">
-            <a:avLst/>
-          </a:prstGeom>
-          <a:noFill/>
-          <a:ln/>
-        </p:spPr>
-        <p:txBody>
-          <a:bodyPr wrap="square" lIns="0" tIns="0" rIns="0" bIns="0" rtlCol="0" anchor="t"/>
-          <a:lstStyle/>
-          <a:p>
-            <a:pPr algn="l" indent="0" marL="0">
-              <a:lnSpc>
-                <a:spcPts val="1430"/>
-              </a:lnSpc>
-              <a:spcBef>
-                <a:spcPts val="1000"/>
-              </a:spcBef>
-              <a:buNone/>
-            </a:pPr>
-            <a:r>
               <a:rPr lang="en-US" sz="1100" dirty="0">
                 <a:solidFill>
                   <a:srgbClr val="5D6870"/>
@@ -3398,57 +3605,34 @@
                 <a:ea typeface="Arial" pitchFamily="34" charset="-122"/>
                 <a:cs typeface="Arial" pitchFamily="34" charset="-120"/>
               </a:rPr>
-              <a:t>Version 1972602e… · SciSpace testimonial</a:t>
+              <a:t>Three articles and three scripts produced.</a:t>
             </a:r>
             <a:endParaRPr lang="en-US" sz="1100" dirty="0"/>
           </a:p>
-          <a:p>
-            <a:pPr algn="l" indent="0" marL="0">
-              <a:lnSpc>
-                <a:spcPts val="1430"/>
-              </a:lnSpc>
-              <a:spcBef>
-                <a:spcPts val="1000"/>
-              </a:spcBef>
-              <a:buNone/>
-            </a:pPr>
-            <a:r>
-              <a:rPr lang="en-US" sz="1100" dirty="0">
-                <a:solidFill>
-                  <a:srgbClr val="5D6870"/>
-                </a:solidFill>
-                <a:latin typeface="Arial" pitchFamily="34" charset="0"/>
-                <a:ea typeface="Arial" pitchFamily="34" charset="-122"/>
-                <a:cs typeface="Arial" pitchFamily="34" charset="-120"/>
-              </a:rPr>
-              <a:t>Timestamped transcript · 00:51–01:11</a:t>
-            </a:r>
-            <a:endParaRPr lang="en-US" sz="1100" dirty="0"/>
-          </a:p>
-        </p:txBody>
-      </p:sp>
-      <p:sp>
-        <p:nvSpPr>
-          <p:cNvPr id="11" name="Text 9"/>
-          <p:cNvSpPr/>
-          <p:nvPr/>
-        </p:nvSpPr>
-        <p:spPr>
-          <a:xfrm>
-            <a:off x="822275" y="3397597"/>
-            <a:ext cx="3295650" cy="636091"/>
+        </p:txBody>
+      </p:sp>
+      <p:sp>
+        <p:nvSpPr>
+          <p:cNvPr id="16" name="Text 14"/>
+          <p:cNvSpPr/>
+          <p:nvPr/>
+        </p:nvSpPr>
+        <p:spPr>
+          <a:xfrm>
+            <a:off x="4800600" y="1917650"/>
+            <a:ext cx="3810000" cy="2120801"/>
           </a:xfrm>
           <a:prstGeom prst="roundRect">
             <a:avLst>
-              <a:gd name="adj" fmla="val 3993"/>
+              <a:gd name="adj" fmla="val 1198"/>
             </a:avLst>
           </a:prstGeom>
           <a:solidFill>
-            <a:srgbClr val="ECEEED"/>
+            <a:srgbClr val="182433"/>
           </a:solidFill>
           <a:ln w="9525">
             <a:solidFill>
-              <a:srgbClr val="ECEEED"/>
+              <a:srgbClr val="182433"/>
             </a:solidFill>
           </a:ln>
         </p:spPr>
@@ -3465,14 +3649,98 @@
       </p:sp>
       <p:sp>
         <p:nvSpPr>
-          <p:cNvPr id="12" name="Text 10"/>
-          <p:cNvSpPr/>
-          <p:nvPr/>
-        </p:nvSpPr>
-        <p:spPr>
-          <a:xfrm>
-            <a:off x="984200" y="3534073"/>
-            <a:ext cx="3031236" cy="363141"/>
+          <p:cNvPr id="17" name="Text 15"/>
+          <p:cNvSpPr/>
+          <p:nvPr/>
+        </p:nvSpPr>
+        <p:spPr>
+          <a:xfrm>
+            <a:off x="5089475" y="2181076"/>
+            <a:ext cx="3296894" cy="164902"/>
+          </a:xfrm>
+          <a:prstGeom prst="rect">
+            <a:avLst/>
+          </a:prstGeom>
+          <a:noFill/>
+          <a:ln/>
+        </p:spPr>
+        <p:txBody>
+          <a:bodyPr wrap="square" lIns="0" tIns="0" rIns="0" bIns="0" rtlCol="0" anchor="t"/>
+          <a:lstStyle/>
+          <a:p>
+            <a:pPr algn="l" indent="0" marL="0">
+              <a:lnSpc>
+                <a:spcPts val="1298"/>
+              </a:lnSpc>
+              <a:buNone/>
+            </a:pPr>
+            <a:r>
+              <a:rPr lang="en-US" sz="1100" b="1" dirty="0">
+                <a:solidFill>
+                  <a:srgbClr val="B58A45"/>
+                </a:solidFill>
+                <a:latin typeface="Arial" pitchFamily="34" charset="0"/>
+                <a:ea typeface="Arial" pitchFamily="34" charset="-122"/>
+                <a:cs typeface="Arial" pitchFamily="34" charset="-120"/>
+              </a:rPr>
+              <a:t>OCTOBER 10 · READY FOR PRODUCTION</a:t>
+            </a:r>
+            <a:endParaRPr lang="en-US" sz="1100" dirty="0"/>
+          </a:p>
+        </p:txBody>
+      </p:sp>
+      <p:sp>
+        <p:nvSpPr>
+          <p:cNvPr id="18" name="Text 16"/>
+          <p:cNvSpPr/>
+          <p:nvPr/>
+        </p:nvSpPr>
+        <p:spPr>
+          <a:xfrm>
+            <a:off x="5089475" y="2574578"/>
+            <a:ext cx="585966" cy="373261"/>
+          </a:xfrm>
+          <a:prstGeom prst="rect">
+            <a:avLst/>
+          </a:prstGeom>
+          <a:noFill/>
+          <a:ln/>
+        </p:spPr>
+        <p:txBody>
+          <a:bodyPr wrap="square" lIns="0" tIns="0" rIns="0" bIns="0" rtlCol="0" anchor="t"/>
+          <a:lstStyle/>
+          <a:p>
+            <a:pPr algn="l" indent="0" marL="0">
+              <a:lnSpc>
+                <a:spcPts val="2940"/>
+              </a:lnSpc>
+              <a:buNone/>
+            </a:pPr>
+            <a:r>
+              <a:rPr lang="en-US" sz="2800" b="1" dirty="0">
+                <a:solidFill>
+                  <a:srgbClr val="FFFFFF"/>
+                </a:solidFill>
+                <a:latin typeface="Arial" pitchFamily="34" charset="0"/>
+                <a:ea typeface="Arial" pitchFamily="34" charset="-122"/>
+                <a:cs typeface="Arial" pitchFamily="34" charset="-120"/>
+              </a:rPr>
+              <a:t>44</a:t>
+            </a:r>
+            <a:endParaRPr lang="en-US" sz="2800" dirty="0"/>
+          </a:p>
+        </p:txBody>
+      </p:sp>
+      <p:sp>
+        <p:nvSpPr>
+          <p:cNvPr id="19" name="Text 17"/>
+          <p:cNvSpPr/>
+          <p:nvPr/>
+        </p:nvSpPr>
+        <p:spPr>
+          <a:xfrm>
+            <a:off x="5089475" y="2947839"/>
+            <a:ext cx="585966" cy="181570"/>
           </a:xfrm>
           <a:prstGeom prst="rect">
             <a:avLst/>
@@ -3493,246 +3761,268 @@
             <a:r>
               <a:rPr lang="en-US" sz="1100" dirty="0">
                 <a:solidFill>
+                  <a:srgbClr val="D8DDDF"/>
+                </a:solidFill>
+                <a:latin typeface="Arial" pitchFamily="34" charset="0"/>
+                <a:ea typeface="Arial" pitchFamily="34" charset="-122"/>
+                <a:cs typeface="Arial" pitchFamily="34" charset="-120"/>
+              </a:rPr>
+              <a:t>extracted</a:t>
+            </a:r>
+            <a:endParaRPr lang="en-US" sz="1100" dirty="0"/>
+          </a:p>
+        </p:txBody>
+      </p:sp>
+      <p:sp>
+        <p:nvSpPr>
+          <p:cNvPr id="20" name="Text 18"/>
+          <p:cNvSpPr/>
+          <p:nvPr/>
+        </p:nvSpPr>
+        <p:spPr>
+          <a:xfrm>
+            <a:off x="6044952" y="2574578"/>
+            <a:ext cx="261408" cy="373261"/>
+          </a:xfrm>
+          <a:prstGeom prst="rect">
+            <a:avLst/>
+          </a:prstGeom>
+          <a:noFill/>
+          <a:ln/>
+        </p:spPr>
+        <p:txBody>
+          <a:bodyPr wrap="square" lIns="0" tIns="0" rIns="0" bIns="0" rtlCol="0" anchor="t"/>
+          <a:lstStyle/>
+          <a:p>
+            <a:pPr algn="l" indent="0" marL="0">
+              <a:lnSpc>
+                <a:spcPts val="2940"/>
+              </a:lnSpc>
+              <a:buNone/>
+            </a:pPr>
+            <a:r>
+              <a:rPr lang="en-US" sz="2800" b="1" dirty="0">
+                <a:solidFill>
+                  <a:srgbClr val="FFFFFF"/>
+                </a:solidFill>
+                <a:latin typeface="Arial" pitchFamily="34" charset="0"/>
+                <a:ea typeface="Arial" pitchFamily="34" charset="-122"/>
+                <a:cs typeface="Arial" pitchFamily="34" charset="-120"/>
+              </a:rPr>
+              <a:t>0</a:t>
+            </a:r>
+            <a:endParaRPr lang="en-US" sz="2800" dirty="0"/>
+          </a:p>
+        </p:txBody>
+      </p:sp>
+      <p:sp>
+        <p:nvSpPr>
+          <p:cNvPr id="21" name="Text 19"/>
+          <p:cNvSpPr/>
+          <p:nvPr/>
+        </p:nvSpPr>
+        <p:spPr>
+          <a:xfrm>
+            <a:off x="6044952" y="2947839"/>
+            <a:ext cx="261408" cy="181570"/>
+          </a:xfrm>
+          <a:prstGeom prst="rect">
+            <a:avLst/>
+          </a:prstGeom>
+          <a:noFill/>
+          <a:ln/>
+        </p:spPr>
+        <p:txBody>
+          <a:bodyPr wrap="square" lIns="0" tIns="0" rIns="0" bIns="0" rtlCol="0" anchor="t"/>
+          <a:lstStyle/>
+          <a:p>
+            <a:pPr algn="l" indent="0" marL="0">
+              <a:lnSpc>
+                <a:spcPts val="1430"/>
+              </a:lnSpc>
+              <a:buNone/>
+            </a:pPr>
+            <a:r>
+              <a:rPr lang="en-US" sz="1100" dirty="0">
+                <a:solidFill>
+                  <a:srgbClr val="D8DDDF"/>
+                </a:solidFill>
+                <a:latin typeface="Arial" pitchFamily="34" charset="0"/>
+                <a:ea typeface="Arial" pitchFamily="34" charset="-122"/>
+                <a:cs typeface="Arial" pitchFamily="34" charset="-120"/>
+              </a:rPr>
+              <a:t>new</a:t>
+            </a:r>
+            <a:endParaRPr lang="en-US" sz="1100" dirty="0"/>
+          </a:p>
+        </p:txBody>
+      </p:sp>
+      <p:sp>
+        <p:nvSpPr>
+          <p:cNvPr id="22" name="Text 20"/>
+          <p:cNvSpPr/>
+          <p:nvPr/>
+        </p:nvSpPr>
+        <p:spPr>
+          <a:xfrm>
+            <a:off x="6682234" y="2574578"/>
+            <a:ext cx="704981" cy="373261"/>
+          </a:xfrm>
+          <a:prstGeom prst="rect">
+            <a:avLst/>
+          </a:prstGeom>
+          <a:noFill/>
+          <a:ln/>
+        </p:spPr>
+        <p:txBody>
+          <a:bodyPr wrap="square" lIns="0" tIns="0" rIns="0" bIns="0" rtlCol="0" anchor="t"/>
+          <a:lstStyle/>
+          <a:p>
+            <a:pPr algn="l" indent="0" marL="0">
+              <a:lnSpc>
+                <a:spcPts val="2940"/>
+              </a:lnSpc>
+              <a:buNone/>
+            </a:pPr>
+            <a:r>
+              <a:rPr lang="en-US" sz="2800" b="1" dirty="0">
+                <a:solidFill>
+                  <a:srgbClr val="FFFFFF"/>
+                </a:solidFill>
+                <a:latin typeface="Arial" pitchFamily="34" charset="0"/>
+                <a:ea typeface="Arial" pitchFamily="34" charset="-122"/>
+                <a:cs typeface="Arial" pitchFamily="34" charset="-120"/>
+              </a:rPr>
+              <a:t>44</a:t>
+            </a:r>
+            <a:endParaRPr lang="en-US" sz="2800" dirty="0"/>
+          </a:p>
+        </p:txBody>
+      </p:sp>
+      <p:sp>
+        <p:nvSpPr>
+          <p:cNvPr id="23" name="Text 21"/>
+          <p:cNvSpPr/>
+          <p:nvPr/>
+        </p:nvSpPr>
+        <p:spPr>
+          <a:xfrm>
+            <a:off x="6682234" y="2947839"/>
+            <a:ext cx="704981" cy="181570"/>
+          </a:xfrm>
+          <a:prstGeom prst="rect">
+            <a:avLst/>
+          </a:prstGeom>
+          <a:noFill/>
+          <a:ln/>
+        </p:spPr>
+        <p:txBody>
+          <a:bodyPr wrap="square" lIns="0" tIns="0" rIns="0" bIns="0" rtlCol="0" anchor="t"/>
+          <a:lstStyle/>
+          <a:p>
+            <a:pPr algn="l" indent="0" marL="0">
+              <a:lnSpc>
+                <a:spcPts val="1430"/>
+              </a:lnSpc>
+              <a:buNone/>
+            </a:pPr>
+            <a:r>
+              <a:rPr lang="en-US" sz="1100" dirty="0">
+                <a:solidFill>
+                  <a:srgbClr val="D8DDDF"/>
+                </a:solidFill>
+                <a:latin typeface="Arial" pitchFamily="34" charset="0"/>
+                <a:ea typeface="Arial" pitchFamily="34" charset="-122"/>
+                <a:cs typeface="Arial" pitchFamily="34" charset="-120"/>
+              </a:rPr>
+              <a:t>unchanged</a:t>
+            </a:r>
+            <a:endParaRPr lang="en-US" sz="1100" dirty="0"/>
+          </a:p>
+        </p:txBody>
+      </p:sp>
+      <p:sp>
+        <p:nvSpPr>
+          <p:cNvPr id="24" name="Text 22"/>
+          <p:cNvSpPr/>
+          <p:nvPr/>
+        </p:nvSpPr>
+        <p:spPr>
+          <a:xfrm>
+            <a:off x="5089475" y="3332559"/>
+            <a:ext cx="3296894" cy="181570"/>
+          </a:xfrm>
+          <a:prstGeom prst="rect">
+            <a:avLst/>
+          </a:prstGeom>
+          <a:noFill/>
+          <a:ln/>
+        </p:spPr>
+        <p:txBody>
+          <a:bodyPr wrap="square" lIns="0" tIns="0" rIns="0" bIns="0" rtlCol="0" anchor="t"/>
+          <a:lstStyle/>
+          <a:p>
+            <a:pPr algn="l" indent="0" marL="0">
+              <a:lnSpc>
+                <a:spcPts val="1430"/>
+              </a:lnSpc>
+              <a:spcBef>
+                <a:spcPts val="1600"/>
+              </a:spcBef>
+              <a:buNone/>
+            </a:pPr>
+            <a:r>
+              <a:rPr lang="en-US" sz="1100" dirty="0">
+                <a:solidFill>
+                  <a:srgbClr val="D8DDDF"/>
+                </a:solidFill>
+                <a:latin typeface="Arial" pitchFamily="34" charset="0"/>
+                <a:ea typeface="Arial" pitchFamily="34" charset="-122"/>
+                <a:cs typeface="Arial" pitchFamily="34" charset="-120"/>
+              </a:rPr>
+              <a:t>Current inputs reused without new versions.</a:t>
+            </a:r>
+            <a:endParaRPr lang="en-US" sz="1100" dirty="0"/>
+          </a:p>
+        </p:txBody>
+      </p:sp>
+      <p:sp>
+        <p:nvSpPr>
+          <p:cNvPr id="25" name="Text 23"/>
+          <p:cNvSpPr/>
+          <p:nvPr/>
+        </p:nvSpPr>
+        <p:spPr>
+          <a:xfrm>
+            <a:off x="533400" y="4568279"/>
+            <a:ext cx="8238744" cy="181570"/>
+          </a:xfrm>
+          <a:prstGeom prst="rect">
+            <a:avLst/>
+          </a:prstGeom>
+          <a:noFill/>
+          <a:ln/>
+        </p:spPr>
+        <p:txBody>
+          <a:bodyPr wrap="square" lIns="0" tIns="0" rIns="0" bIns="0" rtlCol="0" anchor="t"/>
+          <a:lstStyle/>
+          <a:p>
+            <a:pPr algn="l" indent="0" marL="0">
+              <a:lnSpc>
+                <a:spcPts val="1430"/>
+              </a:lnSpc>
+              <a:buNone/>
+            </a:pPr>
+            <a:r>
+              <a:rPr lang="en-US" sz="1100" b="1" dirty="0">
+                <a:solidFill>
                   <a:srgbClr val="182433"/>
                 </a:solidFill>
                 <a:latin typeface="Arial" pitchFamily="34" charset="0"/>
                 <a:ea typeface="Arial" pitchFamily="34" charset="-122"/>
                 <a:cs typeface="Arial" pitchFamily="34" charset="-120"/>
               </a:rPr>
-              <a:t>“outsource the tedious parts” while retaining thinking, analysis, reasoning, and judgment</a:t>
-            </a:r>
-            <a:endParaRPr lang="en-US" sz="1100" dirty="0"/>
-          </a:p>
-        </p:txBody>
-      </p:sp>
-      <p:sp>
-        <p:nvSpPr>
-          <p:cNvPr id="13" name="Text 11"/>
-          <p:cNvSpPr/>
-          <p:nvPr/>
-        </p:nvSpPr>
-        <p:spPr>
-          <a:xfrm>
-            <a:off x="4737199" y="1854101"/>
-            <a:ext cx="3873401" cy="2463701"/>
-          </a:xfrm>
-          <a:prstGeom prst="roundRect">
-            <a:avLst>
-              <a:gd name="adj" fmla="val 1031"/>
-            </a:avLst>
-          </a:prstGeom>
-          <a:solidFill>
-            <a:srgbClr val="F0E8DA"/>
-          </a:solidFill>
-          <a:ln w="9525">
-            <a:solidFill>
-              <a:srgbClr val="F0E8DA"/>
-            </a:solidFill>
-          </a:ln>
-        </p:spPr>
-        <p:txBody>
-          <a:bodyPr wrap="square" rtlCol="0" anchor="ctr"/>
-          <a:lstStyle/>
-          <a:p>
-            <a:pPr indent="0" marL="0">
-              <a:buNone/>
-            </a:pPr>
-            <a:endParaRPr lang="en-US" dirty="0"/>
-          </a:p>
-        </p:txBody>
-      </p:sp>
-      <p:sp>
-        <p:nvSpPr>
-          <p:cNvPr id="14" name="Text 12"/>
-          <p:cNvSpPr/>
-          <p:nvPr/>
-        </p:nvSpPr>
-        <p:spPr>
-          <a:xfrm>
-            <a:off x="5026075" y="2117527"/>
-            <a:ext cx="3361563" cy="164902"/>
-          </a:xfrm>
-          <a:prstGeom prst="rect">
-            <a:avLst/>
-          </a:prstGeom>
-          <a:noFill/>
-          <a:ln/>
-        </p:spPr>
-        <p:txBody>
-          <a:bodyPr wrap="square" lIns="0" tIns="0" rIns="0" bIns="0" rtlCol="0" anchor="t"/>
-          <a:lstStyle/>
-          <a:p>
-            <a:pPr algn="l" indent="0" marL="0">
-              <a:lnSpc>
-                <a:spcPts val="1298"/>
-              </a:lnSpc>
-              <a:buNone/>
-            </a:pPr>
-            <a:r>
-              <a:rPr lang="en-US" sz="1100" b="1" dirty="0">
-                <a:solidFill>
-                  <a:srgbClr val="B58A45"/>
-                </a:solidFill>
-                <a:latin typeface="Arial" pitchFamily="34" charset="0"/>
-                <a:ea typeface="Arial" pitchFamily="34" charset="-122"/>
-                <a:cs typeface="Arial" pitchFamily="34" charset="-120"/>
-              </a:rPr>
-              <a:t>EVIDENCE BOUNDARY</a:t>
-            </a:r>
-            <a:endParaRPr lang="en-US" sz="1100" dirty="0"/>
-          </a:p>
-        </p:txBody>
-      </p:sp>
-      <p:sp>
-        <p:nvSpPr>
-          <p:cNvPr id="15" name="Text 13"/>
-          <p:cNvSpPr/>
-          <p:nvPr/>
-        </p:nvSpPr>
-        <p:spPr>
-          <a:xfrm>
-            <a:off x="5026075" y="2460129"/>
-            <a:ext cx="3361563" cy="539353"/>
-          </a:xfrm>
-          <a:prstGeom prst="rect">
-            <a:avLst/>
-          </a:prstGeom>
-          <a:noFill/>
-          <a:ln/>
-        </p:spPr>
-        <p:txBody>
-          <a:bodyPr wrap="square" lIns="0" tIns="0" rIns="0" bIns="0" rtlCol="0" anchor="t"/>
-          <a:lstStyle/>
-          <a:p>
-            <a:pPr algn="l" indent="0" marL="0">
-              <a:lnSpc>
-                <a:spcPts val="2124"/>
-              </a:lnSpc>
-              <a:spcBef>
-                <a:spcPts val="1400"/>
-              </a:spcBef>
-              <a:buNone/>
-            </a:pPr>
-            <a:r>
-              <a:rPr lang="en-US" sz="1800" b="1" dirty="0">
-                <a:solidFill>
-                  <a:srgbClr val="182433"/>
-                </a:solidFill>
-                <a:latin typeface="Arial" pitchFamily="34" charset="0"/>
-                <a:ea typeface="Arial" pitchFamily="34" charset="-122"/>
-                <a:cs typeface="Arial" pitchFamily="34" charset="-120"/>
-              </a:rPr>
-              <a:t>Keep the workflow perspective</a:t>
-            </a:r>
-            <a:endParaRPr lang="en-US" sz="1800" dirty="0"/>
-          </a:p>
-        </p:txBody>
-      </p:sp>
-      <p:sp>
-        <p:nvSpPr>
-          <p:cNvPr id="16" name="Text 14"/>
-          <p:cNvSpPr/>
-          <p:nvPr/>
-        </p:nvSpPr>
-        <p:spPr>
-          <a:xfrm>
-            <a:off x="5026075" y="3139083"/>
-            <a:ext cx="3361563" cy="363141"/>
-          </a:xfrm>
-          <a:prstGeom prst="rect">
-            <a:avLst/>
-          </a:prstGeom>
-          <a:noFill/>
-          <a:ln/>
-        </p:spPr>
-        <p:txBody>
-          <a:bodyPr wrap="square" lIns="0" tIns="0" rIns="0" bIns="0" rtlCol="0" anchor="t"/>
-          <a:lstStyle/>
-          <a:p>
-            <a:pPr algn="l" indent="0" marL="0">
-              <a:lnSpc>
-                <a:spcPts val="1430"/>
-              </a:lnSpc>
-              <a:spcBef>
-                <a:spcPts val="1100"/>
-              </a:spcBef>
-              <a:buNone/>
-            </a:pPr>
-            <a:r>
-              <a:rPr lang="en-US" sz="1100" dirty="0">
-                <a:solidFill>
-                  <a:srgbClr val="5D6870"/>
-                </a:solidFill>
-                <a:latin typeface="Arial" pitchFamily="34" charset="0"/>
-                <a:ea typeface="Arial" pitchFamily="34" charset="-122"/>
-                <a:cs typeface="Arial" pitchFamily="34" charset="-120"/>
-              </a:rPr>
-              <a:t>Reject the unsupported time-saving comparison as quantitative evidence.</a:t>
-            </a:r>
-            <a:endParaRPr lang="en-US" sz="1100" dirty="0"/>
-          </a:p>
-        </p:txBody>
-      </p:sp>
-      <p:sp>
-        <p:nvSpPr>
-          <p:cNvPr id="17" name="Shape 15"/>
-          <p:cNvSpPr/>
-          <p:nvPr/>
-        </p:nvSpPr>
-        <p:spPr>
-          <a:xfrm>
-            <a:off x="5026075" y="3684687"/>
-            <a:ext cx="3295650" cy="0"/>
-          </a:xfrm>
-          <a:prstGeom prst="line">
-            <a:avLst/>
-          </a:prstGeom>
-          <a:noFill/>
-          <a:ln w="9525">
-            <a:solidFill>
-              <a:srgbClr val="CDD2D3"/>
-            </a:solidFill>
-            <a:prstDash val="solid"/>
-          </a:ln>
-        </p:spPr>
-      </p:sp>
-      <p:sp>
-        <p:nvSpPr>
-          <p:cNvPr id="18" name="Text 16"/>
-          <p:cNvSpPr/>
-          <p:nvPr/>
-        </p:nvSpPr>
-        <p:spPr>
-          <a:xfrm>
-            <a:off x="5026075" y="3803749"/>
-            <a:ext cx="3361563" cy="363141"/>
-          </a:xfrm>
-          <a:prstGeom prst="rect">
-            <a:avLst/>
-          </a:prstGeom>
-          <a:noFill/>
-          <a:ln/>
-        </p:spPr>
-        <p:txBody>
-          <a:bodyPr wrap="square" lIns="0" tIns="0" rIns="0" bIns="0" rtlCol="0" anchor="t"/>
-          <a:lstStyle/>
-          <a:p>
-            <a:pPr algn="l" indent="0" marL="0">
-              <a:lnSpc>
-                <a:spcPts val="1430"/>
-              </a:lnSpc>
-              <a:buNone/>
-            </a:pPr>
-            <a:r>
-              <a:rPr lang="en-US" sz="1100" dirty="0">
-                <a:solidFill>
-                  <a:srgbClr val="5D6870"/>
-                </a:solidFill>
-                <a:latin typeface="Arial" pitchFamily="34" charset="0"/>
-                <a:ea typeface="Arial" pitchFamily="34" charset="-122"/>
-                <a:cs typeface="Arial" pitchFamily="34" charset="-120"/>
-              </a:rPr>
-              <a:t>Commercial incentive disclosed · no causal or prevalence claim</a:t>
+              <a:t>changes.jsonl records identity and version status for every observation.</a:t>
             </a:r>
             <a:endParaRPr lang="en-US" sz="1100" dirty="0"/>
           </a:p>
@@ -3746,9 +4036,9 @@
 </p:sld>
 </file>
 
-<file path=ppt/slides/slide6.xml><?xml version="1.0" encoding="utf-8"?>
+<file path=ppt/slides/slide5.xml><?xml version="1.0" encoding="utf-8"?>
 <p:sld xmlns:a="http://schemas.openxmlformats.org/drawingml/2006/main" xmlns:r="http://schemas.openxmlformats.org/officeDocument/2006/relationships" xmlns:p="http://schemas.openxmlformats.org/presentationml/2006/main">
-  <p:cSld name="Slide 6">
+  <p:cSld name="Slide 5">
     <p:bg>
       <p:bgPr>
         <a:solidFill>
@@ -3848,7 +4138,7 @@
                 <a:ea typeface="Arial" pitchFamily="34" charset="-122"/>
                 <a:cs typeface="Arial" pitchFamily="34" charset="-120"/>
               </a:rPr>
-              <a:t>PUBLISHED-CLAIM TRACE</a:t>
+              <a:t>HUMAN EDITORIAL CORRECTION</a:t>
             </a:r>
             <a:endParaRPr lang="en-US" sz="1100" dirty="0"/>
           </a:p>
@@ -3920,7 +4210,7 @@
                 <a:ea typeface="Arial" pitchFamily="34" charset="-122"/>
                 <a:cs typeface="Arial" pitchFamily="34" charset="-120"/>
               </a:rPr>
-              <a:t>DECISION TO AUDIENCE FORMATS</a:t>
+              <a:t>POLICY REVISION</a:t>
             </a:r>
             <a:endParaRPr lang="en-US" sz="1100" dirty="0"/>
           </a:p>
@@ -3965,7 +4255,7 @@
                 <a:ea typeface="Arial" pitchFamily="34" charset="-122"/>
                 <a:cs typeface="Arial" pitchFamily="34" charset="-120"/>
               </a:rPr>
-              <a:t>The same bounded claim travels through every artifact</a:t>
+              <a:t>Rejecting one claim should not discard the useful source perspective</a:t>
             </a:r>
             <a:endParaRPr lang="en-US" sz="2800" dirty="0"/>
           </a:p>
@@ -3980,19 +4270,19 @@
         <p:spPr>
           <a:xfrm>
             <a:off x="533400" y="1917650"/>
-            <a:ext cx="1473101" cy="2108150"/>
+            <a:ext cx="2336899" cy="2108150"/>
           </a:xfrm>
           <a:prstGeom prst="roundRect">
             <a:avLst>
-              <a:gd name="adj" fmla="val 1724"/>
+              <a:gd name="adj" fmla="val 1205"/>
             </a:avLst>
           </a:prstGeom>
           <a:solidFill>
-            <a:srgbClr val="E7EFEE"/>
+            <a:srgbClr val="F0E8DA"/>
           </a:solidFill>
           <a:ln w="9525">
             <a:solidFill>
-              <a:srgbClr val="E7EFEE"/>
+              <a:srgbClr val="F0E8DA"/>
             </a:solidFill>
           </a:ln>
         </p:spPr>
@@ -4015,8 +4305,8 @@
         </p:nvSpPr>
         <p:spPr>
           <a:xfrm>
-            <a:off x="720626" y="2155775"/>
-            <a:ext cx="1120622" cy="329803"/>
+            <a:off x="771525" y="2181076"/>
+            <a:ext cx="1897862" cy="164902"/>
           </a:xfrm>
           <a:prstGeom prst="rect">
             <a:avLst/>
@@ -4037,13 +4327,13 @@
             <a:r>
               <a:rPr lang="en-US" sz="1100" b="1" dirty="0">
                 <a:solidFill>
-                  <a:srgbClr val="2F6F72"/>
-                </a:solidFill>
-                <a:latin typeface="Arial" pitchFamily="34" charset="0"/>
-                <a:ea typeface="Arial" pitchFamily="34" charset="-122"/>
-                <a:cs typeface="Arial" pitchFamily="34" charset="-120"/>
-              </a:rPr>
-              <a:t>01 · EVIDENCE</a:t>
+                  <a:srgbClr val="B58A45"/>
+                </a:solidFill>
+                <a:latin typeface="Arial" pitchFamily="34" charset="0"/>
+                <a:ea typeface="Arial" pitchFamily="34" charset="-122"/>
+                <a:cs typeface="Arial" pitchFamily="34" charset="-120"/>
+              </a:rPr>
+              <a:t>BEFORE</a:t>
             </a:r>
             <a:endParaRPr lang="en-US" sz="1100" dirty="0"/>
           </a:p>
@@ -4057,8 +4347,8 @@
         </p:nvSpPr>
         <p:spPr>
           <a:xfrm>
-            <a:off x="720626" y="2701379"/>
-            <a:ext cx="1120622" cy="539353"/>
+            <a:off x="771525" y="2536478"/>
+            <a:ext cx="1897862" cy="539353"/>
           </a:xfrm>
           <a:prstGeom prst="rect">
             <a:avLst/>
@@ -4075,7 +4365,7 @@
                 <a:spcPts val="2124"/>
               </a:lnSpc>
               <a:spcBef>
-                <a:spcPts val="1700"/>
+                <a:spcPts val="1500"/>
               </a:spcBef>
               <a:buNone/>
             </a:pPr>
@@ -4088,7 +4378,7 @@
                 <a:ea typeface="Arial" pitchFamily="34" charset="-122"/>
                 <a:cs typeface="Arial" pitchFamily="34" charset="-120"/>
               </a:rPr>
-              <a:t>Version + segments</a:t>
+              <a:t>Reject whole item</a:t>
             </a:r>
             <a:endParaRPr lang="en-US" sz="1800" dirty="0"/>
           </a:p>
@@ -4102,8 +4392,8 @@
         </p:nvSpPr>
         <p:spPr>
           <a:xfrm>
-            <a:off x="720626" y="3405783"/>
-            <a:ext cx="1120622" cy="181570"/>
+            <a:off x="771525" y="3240881"/>
+            <a:ext cx="1897862" cy="544711"/>
           </a:xfrm>
           <a:prstGeom prst="rect">
             <a:avLst/>
@@ -4133,7 +4423,7 @@
                 <a:ea typeface="Arial" pitchFamily="34" charset="-122"/>
                 <a:cs typeface="Arial" pitchFamily="34" charset="-120"/>
               </a:rPr>
-              <a:t>00:51–01:11</a:t>
+              <a:t>Unsupported efficiency comparison dominated the decision.</a:t>
             </a:r>
             <a:endParaRPr lang="en-US" sz="1100" dirty="0"/>
           </a:p>
@@ -4147,12 +4437,54 @@
         </p:nvSpPr>
         <p:spPr>
           <a:xfrm>
-            <a:off x="2184202" y="1917650"/>
-            <a:ext cx="1473101" cy="2108150"/>
+            <a:off x="2994456" y="2819251"/>
+            <a:ext cx="284937" cy="304800"/>
+          </a:xfrm>
+          <a:prstGeom prst="rect">
+            <a:avLst/>
+          </a:prstGeom>
+          <a:noFill/>
+          <a:ln/>
+        </p:spPr>
+        <p:txBody>
+          <a:bodyPr wrap="square" lIns="0" tIns="0" rIns="0" bIns="0" rtlCol="0" anchor="t"/>
+          <a:lstStyle/>
+          <a:p>
+            <a:pPr algn="ctr" indent="0" marL="0">
+              <a:lnSpc>
+                <a:spcPts val="2400"/>
+              </a:lnSpc>
+              <a:buNone/>
+            </a:pPr>
+            <a:r>
+              <a:rPr lang="en-US" sz="2400" dirty="0">
+                <a:solidFill>
+                  <a:srgbClr val="2F6F72"/>
+                </a:solidFill>
+                <a:latin typeface="Arial" pitchFamily="34" charset="0"/>
+                <a:ea typeface="Arial" pitchFamily="34" charset="-122"/>
+                <a:cs typeface="Arial" pitchFamily="34" charset="-120"/>
+              </a:rPr>
+              <a:t>→</a:t>
+            </a:r>
+            <a:endParaRPr lang="en-US" sz="2400" dirty="0"/>
+          </a:p>
+        </p:txBody>
+      </p:sp>
+      <p:sp>
+        <p:nvSpPr>
+          <p:cNvPr id="12" name="Text 10"/>
+          <p:cNvSpPr/>
+          <p:nvPr/>
+        </p:nvSpPr>
+        <p:spPr>
+          <a:xfrm>
+            <a:off x="3403550" y="1917650"/>
+            <a:ext cx="2336899" cy="2108150"/>
           </a:xfrm>
           <a:prstGeom prst="roundRect">
             <a:avLst>
-              <a:gd name="adj" fmla="val 1724"/>
+              <a:gd name="adj" fmla="val 1205"/>
             </a:avLst>
           </a:prstGeom>
           <a:solidFill>
@@ -4177,14 +4509,14 @@
       </p:sp>
       <p:sp>
         <p:nvSpPr>
-          <p:cNvPr id="12" name="Text 10"/>
-          <p:cNvSpPr/>
-          <p:nvPr/>
-        </p:nvSpPr>
-        <p:spPr>
-          <a:xfrm>
-            <a:off x="2371427" y="2155775"/>
-            <a:ext cx="1120622" cy="164902"/>
+          <p:cNvPr id="13" name="Text 11"/>
+          <p:cNvSpPr/>
+          <p:nvPr/>
+        </p:nvSpPr>
+        <p:spPr>
+          <a:xfrm>
+            <a:off x="3641675" y="2181076"/>
+            <a:ext cx="1897862" cy="164902"/>
           </a:xfrm>
           <a:prstGeom prst="rect">
             <a:avLst/>
@@ -4211,7 +4543,7 @@
                 <a:ea typeface="Arial" pitchFamily="34" charset="-122"/>
                 <a:cs typeface="Arial" pitchFamily="34" charset="-120"/>
               </a:rPr>
-              <a:t>02 · DECISION</a:t>
+              <a:t>HUMAN REVIEW</a:t>
             </a:r>
             <a:endParaRPr lang="en-US" sz="1100" dirty="0"/>
           </a:p>
@@ -4219,14 +4551,14 @@
       </p:sp>
       <p:sp>
         <p:nvSpPr>
-          <p:cNvPr id="13" name="Text 11"/>
-          <p:cNvSpPr/>
-          <p:nvPr/>
-        </p:nvSpPr>
-        <p:spPr>
-          <a:xfrm>
-            <a:off x="2371427" y="2536478"/>
-            <a:ext cx="1120622" cy="809030"/>
+          <p:cNvPr id="14" name="Text 12"/>
+          <p:cNvSpPr/>
+          <p:nvPr/>
+        </p:nvSpPr>
+        <p:spPr>
+          <a:xfrm>
+            <a:off x="3641675" y="2536478"/>
+            <a:ext cx="1897862" cy="539353"/>
           </a:xfrm>
           <a:prstGeom prst="rect">
             <a:avLst/>
@@ -4243,7 +4575,7 @@
                 <a:spcPts val="2124"/>
               </a:lnSpc>
               <a:spcBef>
-                <a:spcPts val="1700"/>
+                <a:spcPts val="1500"/>
               </a:spcBef>
               <a:buNone/>
             </a:pPr>
@@ -4256,7 +4588,7 @@
                 <a:ea typeface="Arial" pitchFamily="34" charset="-122"/>
                 <a:cs typeface="Arial" pitchFamily="34" charset="-120"/>
               </a:rPr>
-              <a:t>Accept with limits</a:t>
+              <a:t>Separate the claims</a:t>
             </a:r>
             <a:endParaRPr lang="en-US" sz="1800" dirty="0"/>
           </a:p>
@@ -4264,14 +4596,14 @@
       </p:sp>
       <p:sp>
         <p:nvSpPr>
-          <p:cNvPr id="14" name="Text 12"/>
-          <p:cNvSpPr/>
-          <p:nvPr/>
-        </p:nvSpPr>
-        <p:spPr>
-          <a:xfrm>
-            <a:off x="2371427" y="3510558"/>
-            <a:ext cx="1120622" cy="181570"/>
+          <p:cNvPr id="15" name="Text 13"/>
+          <p:cNvSpPr/>
+          <p:nvPr/>
+        </p:nvSpPr>
+        <p:spPr>
+          <a:xfrm>
+            <a:off x="3641675" y="3240881"/>
+            <a:ext cx="1897862" cy="544711"/>
           </a:xfrm>
           <a:prstGeom prst="rect">
             <a:avLst/>
@@ -4301,7 +4633,7 @@
                 <a:ea typeface="Arial" pitchFamily="34" charset="-122"/>
                 <a:cs typeface="Arial" pitchFamily="34" charset="-120"/>
               </a:rPr>
-              <a:t>Pieces 02 · 03</a:t>
+              <a:t>Keep the relevant testimony; exclude the unsupported number.</a:t>
             </a:r>
             <a:endParaRPr lang="en-US" sz="1100" dirty="0"/>
           </a:p>
@@ -4309,354 +4641,60 @@
       </p:sp>
       <p:sp>
         <p:nvSpPr>
-          <p:cNvPr id="15" name="Text 13"/>
-          <p:cNvSpPr/>
-          <p:nvPr/>
-        </p:nvSpPr>
-        <p:spPr>
-          <a:xfrm>
-            <a:off x="3835003" y="1917650"/>
-            <a:ext cx="1473101" cy="2108150"/>
+          <p:cNvPr id="16" name="Text 14"/>
+          <p:cNvSpPr/>
+          <p:nvPr/>
+        </p:nvSpPr>
+        <p:spPr>
+          <a:xfrm>
+            <a:off x="5864606" y="2819251"/>
+            <a:ext cx="284937" cy="304800"/>
+          </a:xfrm>
+          <a:prstGeom prst="rect">
+            <a:avLst/>
+          </a:prstGeom>
+          <a:noFill/>
+          <a:ln/>
+        </p:spPr>
+        <p:txBody>
+          <a:bodyPr wrap="square" lIns="0" tIns="0" rIns="0" bIns="0" rtlCol="0" anchor="t"/>
+          <a:lstStyle/>
+          <a:p>
+            <a:pPr algn="ctr" indent="0" marL="0">
+              <a:lnSpc>
+                <a:spcPts val="2400"/>
+              </a:lnSpc>
+              <a:buNone/>
+            </a:pPr>
+            <a:r>
+              <a:rPr lang="en-US" sz="2400" dirty="0">
+                <a:solidFill>
+                  <a:srgbClr val="2F6F72"/>
+                </a:solidFill>
+                <a:latin typeface="Arial" pitchFamily="34" charset="0"/>
+                <a:ea typeface="Arial" pitchFamily="34" charset="-122"/>
+                <a:cs typeface="Arial" pitchFamily="34" charset="-120"/>
+              </a:rPr>
+              <a:t>→</a:t>
+            </a:r>
+            <a:endParaRPr lang="en-US" sz="2400" dirty="0"/>
+          </a:p>
+        </p:txBody>
+      </p:sp>
+      <p:sp>
+        <p:nvSpPr>
+          <p:cNvPr id="17" name="Text 15"/>
+          <p:cNvSpPr/>
+          <p:nvPr/>
+        </p:nvSpPr>
+        <p:spPr>
+          <a:xfrm>
+            <a:off x="6273701" y="1917650"/>
+            <a:ext cx="2336899" cy="2108150"/>
           </a:xfrm>
           <a:prstGeom prst="roundRect">
             <a:avLst>
-              <a:gd name="adj" fmla="val 1724"/>
-            </a:avLst>
-          </a:prstGeom>
-          <a:solidFill>
-            <a:srgbClr val="F0E8DA"/>
-          </a:solidFill>
-          <a:ln w="9525">
-            <a:solidFill>
-              <a:srgbClr val="F0E8DA"/>
-            </a:solidFill>
-          </a:ln>
-        </p:spPr>
-        <p:txBody>
-          <a:bodyPr wrap="square" rtlCol="0" anchor="ctr"/>
-          <a:lstStyle/>
-          <a:p>
-            <a:pPr indent="0" marL="0">
-              <a:buNone/>
-            </a:pPr>
-            <a:endParaRPr lang="en-US" dirty="0"/>
-          </a:p>
-        </p:txBody>
-      </p:sp>
-      <p:sp>
-        <p:nvSpPr>
-          <p:cNvPr id="16" name="Text 14"/>
-          <p:cNvSpPr/>
-          <p:nvPr/>
-        </p:nvSpPr>
-        <p:spPr>
-          <a:xfrm>
-            <a:off x="4022229" y="2155775"/>
-            <a:ext cx="1120622" cy="164902"/>
-          </a:xfrm>
-          <a:prstGeom prst="rect">
-            <a:avLst/>
-          </a:prstGeom>
-          <a:noFill/>
-          <a:ln/>
-        </p:spPr>
-        <p:txBody>
-          <a:bodyPr wrap="square" lIns="0" tIns="0" rIns="0" bIns="0" rtlCol="0" anchor="t"/>
-          <a:lstStyle/>
-          <a:p>
-            <a:pPr algn="l" indent="0" marL="0">
-              <a:lnSpc>
-                <a:spcPts val="1298"/>
-              </a:lnSpc>
-              <a:buNone/>
-            </a:pPr>
-            <a:r>
-              <a:rPr lang="en-US" sz="1100" b="1" dirty="0">
-                <a:solidFill>
-                  <a:srgbClr val="2F6F72"/>
-                </a:solidFill>
-                <a:latin typeface="Arial" pitchFamily="34" charset="0"/>
-                <a:ea typeface="Arial" pitchFamily="34" charset="-122"/>
-                <a:cs typeface="Arial" pitchFamily="34" charset="-120"/>
-              </a:rPr>
-              <a:t>03 · BRIEF</a:t>
-            </a:r>
-            <a:endParaRPr lang="en-US" sz="1100" dirty="0"/>
-          </a:p>
-        </p:txBody>
-      </p:sp>
-      <p:sp>
-        <p:nvSpPr>
-          <p:cNvPr id="17" name="Text 15"/>
-          <p:cNvSpPr/>
-          <p:nvPr/>
-        </p:nvSpPr>
-        <p:spPr>
-          <a:xfrm>
-            <a:off x="4022229" y="2536478"/>
-            <a:ext cx="1120622" cy="269677"/>
-          </a:xfrm>
-          <a:prstGeom prst="rect">
-            <a:avLst/>
-          </a:prstGeom>
-          <a:noFill/>
-          <a:ln/>
-        </p:spPr>
-        <p:txBody>
-          <a:bodyPr wrap="square" lIns="0" tIns="0" rIns="0" bIns="0" rtlCol="0" anchor="t"/>
-          <a:lstStyle/>
-          <a:p>
-            <a:pPr algn="l" indent="0" marL="0">
-              <a:lnSpc>
-                <a:spcPts val="2124"/>
-              </a:lnSpc>
-              <a:spcBef>
-                <a:spcPts val="1700"/>
-              </a:spcBef>
-              <a:buNone/>
-            </a:pPr>
-            <a:r>
-              <a:rPr lang="en-US" sz="1800" b="1" dirty="0">
-                <a:solidFill>
-                  <a:srgbClr val="182433"/>
-                </a:solidFill>
-                <a:latin typeface="Arial" pitchFamily="34" charset="0"/>
-                <a:ea typeface="Arial" pitchFamily="34" charset="-122"/>
-                <a:cs typeface="Arial" pitchFamily="34" charset="-120"/>
-              </a:rPr>
-              <a:t>03-c4</a:t>
-            </a:r>
-            <a:endParaRPr lang="en-US" sz="1800" dirty="0"/>
-          </a:p>
-        </p:txBody>
-      </p:sp>
-      <p:sp>
-        <p:nvSpPr>
-          <p:cNvPr id="18" name="Text 16"/>
-          <p:cNvSpPr/>
-          <p:nvPr/>
-        </p:nvSpPr>
-        <p:spPr>
-          <a:xfrm>
-            <a:off x="4022229" y="2971205"/>
-            <a:ext cx="1120622" cy="181570"/>
-          </a:xfrm>
-          <a:prstGeom prst="rect">
-            <a:avLst/>
-          </a:prstGeom>
-          <a:noFill/>
-          <a:ln/>
-        </p:spPr>
-        <p:txBody>
-          <a:bodyPr wrap="square" lIns="0" tIns="0" rIns="0" bIns="0" rtlCol="0" anchor="t"/>
-          <a:lstStyle/>
-          <a:p>
-            <a:pPr algn="l" indent="0" marL="0">
-              <a:lnSpc>
-                <a:spcPts val="1430"/>
-              </a:lnSpc>
-              <a:spcBef>
-                <a:spcPts val="1300"/>
-              </a:spcBef>
-              <a:buNone/>
-            </a:pPr>
-            <a:r>
-              <a:rPr lang="en-US" sz="1100" dirty="0">
-                <a:solidFill>
-                  <a:srgbClr val="5D6870"/>
-                </a:solidFill>
-                <a:latin typeface="Arial" pitchFamily="34" charset="0"/>
-                <a:ea typeface="Arial" pitchFamily="34" charset="-122"/>
-                <a:cs typeface="Arial" pitchFamily="34" charset="-120"/>
-              </a:rPr>
-              <a:t>Exact locators</a:t>
-            </a:r>
-            <a:endParaRPr lang="en-US" sz="1100" dirty="0"/>
-          </a:p>
-        </p:txBody>
-      </p:sp>
-      <p:sp>
-        <p:nvSpPr>
-          <p:cNvPr id="19" name="Text 17"/>
-          <p:cNvSpPr/>
-          <p:nvPr/>
-        </p:nvSpPr>
-        <p:spPr>
-          <a:xfrm>
-            <a:off x="5485805" y="1917650"/>
-            <a:ext cx="1473101" cy="2108150"/>
-          </a:xfrm>
-          <a:prstGeom prst="roundRect">
-            <a:avLst>
-              <a:gd name="adj" fmla="val 1724"/>
-            </a:avLst>
-          </a:prstGeom>
-          <a:solidFill>
-            <a:srgbClr val="FFFFFF"/>
-          </a:solidFill>
-          <a:ln w="9525">
-            <a:solidFill>
-              <a:srgbClr val="CDD2D3"/>
-            </a:solidFill>
-          </a:ln>
-        </p:spPr>
-        <p:txBody>
-          <a:bodyPr wrap="square" rtlCol="0" anchor="ctr"/>
-          <a:lstStyle/>
-          <a:p>
-            <a:pPr indent="0" marL="0">
-              <a:buNone/>
-            </a:pPr>
-            <a:endParaRPr lang="en-US" dirty="0"/>
-          </a:p>
-        </p:txBody>
-      </p:sp>
-      <p:sp>
-        <p:nvSpPr>
-          <p:cNvPr id="20" name="Text 18"/>
-          <p:cNvSpPr/>
-          <p:nvPr/>
-        </p:nvSpPr>
-        <p:spPr>
-          <a:xfrm>
-            <a:off x="5673030" y="2155775"/>
-            <a:ext cx="1120622" cy="164902"/>
-          </a:xfrm>
-          <a:prstGeom prst="rect">
-            <a:avLst/>
-          </a:prstGeom>
-          <a:noFill/>
-          <a:ln/>
-        </p:spPr>
-        <p:txBody>
-          <a:bodyPr wrap="square" lIns="0" tIns="0" rIns="0" bIns="0" rtlCol="0" anchor="t"/>
-          <a:lstStyle/>
-          <a:p>
-            <a:pPr algn="l" indent="0" marL="0">
-              <a:lnSpc>
-                <a:spcPts val="1298"/>
-              </a:lnSpc>
-              <a:buNone/>
-            </a:pPr>
-            <a:r>
-              <a:rPr lang="en-US" sz="1100" b="1" dirty="0">
-                <a:solidFill>
-                  <a:srgbClr val="2F6F72"/>
-                </a:solidFill>
-                <a:latin typeface="Arial" pitchFamily="34" charset="0"/>
-                <a:ea typeface="Arial" pitchFamily="34" charset="-122"/>
-                <a:cs typeface="Arial" pitchFamily="34" charset="-120"/>
-              </a:rPr>
-              <a:t>04 · OUTPUTS</a:t>
-            </a:r>
-            <a:endParaRPr lang="en-US" sz="1100" dirty="0"/>
-          </a:p>
-        </p:txBody>
-      </p:sp>
-      <p:sp>
-        <p:nvSpPr>
-          <p:cNvPr id="21" name="Text 19"/>
-          <p:cNvSpPr/>
-          <p:nvPr/>
-        </p:nvSpPr>
-        <p:spPr>
-          <a:xfrm>
-            <a:off x="5673030" y="2536478"/>
-            <a:ext cx="1120622" cy="539353"/>
-          </a:xfrm>
-          <a:prstGeom prst="rect">
-            <a:avLst/>
-          </a:prstGeom>
-          <a:noFill/>
-          <a:ln/>
-        </p:spPr>
-        <p:txBody>
-          <a:bodyPr wrap="square" lIns="0" tIns="0" rIns="0" bIns="0" rtlCol="0" anchor="t"/>
-          <a:lstStyle/>
-          <a:p>
-            <a:pPr algn="l" indent="0" marL="0">
-              <a:lnSpc>
-                <a:spcPts val="2124"/>
-              </a:lnSpc>
-              <a:spcBef>
-                <a:spcPts val="1700"/>
-              </a:spcBef>
-              <a:buNone/>
-            </a:pPr>
-            <a:r>
-              <a:rPr lang="en-US" sz="1800" b="1" dirty="0">
-                <a:solidFill>
-                  <a:srgbClr val="182433"/>
-                </a:solidFill>
-                <a:latin typeface="Arial" pitchFamily="34" charset="0"/>
-                <a:ea typeface="Arial" pitchFamily="34" charset="-122"/>
-                <a:cs typeface="Arial" pitchFamily="34" charset="-120"/>
-              </a:rPr>
-              <a:t>Article + video</a:t>
-            </a:r>
-            <a:endParaRPr lang="en-US" sz="1800" dirty="0"/>
-          </a:p>
-        </p:txBody>
-      </p:sp>
-      <p:sp>
-        <p:nvSpPr>
-          <p:cNvPr id="22" name="Text 20"/>
-          <p:cNvSpPr/>
-          <p:nvPr/>
-        </p:nvSpPr>
-        <p:spPr>
-          <a:xfrm>
-            <a:off x="5673030" y="3240881"/>
-            <a:ext cx="1120622" cy="363141"/>
-          </a:xfrm>
-          <a:prstGeom prst="rect">
-            <a:avLst/>
-          </a:prstGeom>
-          <a:noFill/>
-          <a:ln/>
-        </p:spPr>
-        <p:txBody>
-          <a:bodyPr wrap="square" lIns="0" tIns="0" rIns="0" bIns="0" rtlCol="0" anchor="t"/>
-          <a:lstStyle/>
-          <a:p>
-            <a:pPr algn="l" indent="0" marL="0">
-              <a:lnSpc>
-                <a:spcPts val="1430"/>
-              </a:lnSpc>
-              <a:spcBef>
-                <a:spcPts val="1300"/>
-              </a:spcBef>
-              <a:buNone/>
-            </a:pPr>
-            <a:r>
-              <a:rPr lang="en-US" sz="1100" dirty="0">
-                <a:solidFill>
-                  <a:srgbClr val="5D6870"/>
-                </a:solidFill>
-                <a:latin typeface="Arial" pitchFamily="34" charset="0"/>
-                <a:ea typeface="Arial" pitchFamily="34" charset="-122"/>
-                <a:cs typeface="Arial" pitchFamily="34" charset="-120"/>
-              </a:rPr>
-              <a:t>Same claim marker</a:t>
-            </a:r>
-            <a:endParaRPr lang="en-US" sz="1100" dirty="0"/>
-          </a:p>
-        </p:txBody>
-      </p:sp>
-      <p:sp>
-        <p:nvSpPr>
-          <p:cNvPr id="23" name="Text 21"/>
-          <p:cNvSpPr/>
-          <p:nvPr/>
-        </p:nvSpPr>
-        <p:spPr>
-          <a:xfrm>
-            <a:off x="7136606" y="1917650"/>
-            <a:ext cx="1473101" cy="2108150"/>
-          </a:xfrm>
-          <a:prstGeom prst="roundRect">
-            <a:avLst>
-              <a:gd name="adj" fmla="val 1724"/>
+              <a:gd name="adj" fmla="val 1205"/>
             </a:avLst>
           </a:prstGeom>
           <a:solidFill>
@@ -4681,14 +4719,14 @@
       </p:sp>
       <p:sp>
         <p:nvSpPr>
-          <p:cNvPr id="24" name="Text 22"/>
-          <p:cNvSpPr/>
-          <p:nvPr/>
-        </p:nvSpPr>
-        <p:spPr>
-          <a:xfrm>
-            <a:off x="7323832" y="2155775"/>
-            <a:ext cx="1120622" cy="329803"/>
+          <p:cNvPr id="18" name="Text 16"/>
+          <p:cNvSpPr/>
+          <p:nvPr/>
+        </p:nvSpPr>
+        <p:spPr>
+          <a:xfrm>
+            <a:off x="6511826" y="2181076"/>
+            <a:ext cx="1897862" cy="164902"/>
           </a:xfrm>
           <a:prstGeom prst="rect">
             <a:avLst/>
@@ -4715,7 +4753,7 @@
                 <a:ea typeface="Arial" pitchFamily="34" charset="-122"/>
                 <a:cs typeface="Arial" pitchFamily="34" charset="-120"/>
               </a:rPr>
-              <a:t>05 · SOURCE NOTE</a:t>
+              <a:t>POLICY V3</a:t>
             </a:r>
             <a:endParaRPr lang="en-US" sz="1100" dirty="0"/>
           </a:p>
@@ -4723,14 +4761,14 @@
       </p:sp>
       <p:sp>
         <p:nvSpPr>
-          <p:cNvPr id="25" name="Text 23"/>
-          <p:cNvSpPr/>
-          <p:nvPr/>
-        </p:nvSpPr>
-        <p:spPr>
-          <a:xfrm>
-            <a:off x="7323832" y="2701379"/>
-            <a:ext cx="1120622" cy="539353"/>
+          <p:cNvPr id="19" name="Text 17"/>
+          <p:cNvSpPr/>
+          <p:nvPr/>
+        </p:nvSpPr>
+        <p:spPr>
+          <a:xfrm>
+            <a:off x="6511826" y="2536478"/>
+            <a:ext cx="1897862" cy="539353"/>
           </a:xfrm>
           <a:prstGeom prst="rect">
             <a:avLst/>
@@ -4747,7 +4785,7 @@
                 <a:spcPts val="2124"/>
               </a:lnSpc>
               <a:spcBef>
-                <a:spcPts val="1700"/>
+                <a:spcPts val="1500"/>
               </a:spcBef>
               <a:buNone/>
             </a:pPr>
@@ -4760,7 +4798,7 @@
                 <a:ea typeface="Arial" pitchFamily="34" charset="-122"/>
                 <a:cs typeface="Arial" pitchFamily="34" charset="-120"/>
               </a:rPr>
-              <a:t>Viewer trace</a:t>
+              <a:t>Accept with limits</a:t>
             </a:r>
             <a:endParaRPr lang="en-US" sz="1800" dirty="0"/>
           </a:p>
@@ -4768,14 +4806,14 @@
       </p:sp>
       <p:sp>
         <p:nvSpPr>
-          <p:cNvPr id="26" name="Text 24"/>
-          <p:cNvSpPr/>
-          <p:nvPr/>
-        </p:nvSpPr>
-        <p:spPr>
-          <a:xfrm>
-            <a:off x="7323832" y="3405783"/>
-            <a:ext cx="1120622" cy="363141"/>
+          <p:cNvPr id="20" name="Text 18"/>
+          <p:cNvSpPr/>
+          <p:nvPr/>
+        </p:nvSpPr>
+        <p:spPr>
+          <a:xfrm>
+            <a:off x="6511826" y="3240881"/>
+            <a:ext cx="1897862" cy="363141"/>
           </a:xfrm>
           <a:prstGeom prst="rect">
             <a:avLst/>
@@ -4805,7 +4843,7 @@
                 <a:ea typeface="Arial" pitchFamily="34" charset="-122"/>
                 <a:cs typeface="Arial" pitchFamily="34" charset="-120"/>
               </a:rPr>
-              <a:t>Resolved passage</a:t>
+              <a:t>Pieces 02 and 03 · perspective only.</a:t>
             </a:r>
             <a:endParaRPr lang="en-US" sz="1100" dirty="0"/>
           </a:p>
@@ -4813,7 +4851,7 @@
       </p:sp>
       <p:sp>
         <p:nvSpPr>
-          <p:cNvPr id="27" name="Text 25"/>
+          <p:cNvPr id="21" name="Text 19"/>
           <p:cNvSpPr/>
           <p:nvPr/>
         </p:nvSpPr>
@@ -4847,7 +4885,7 @@
                 <a:ea typeface="Arial" pitchFamily="34" charset="-122"/>
                 <a:cs typeface="Arial" pitchFamily="34" charset="-120"/>
               </a:rPr>
-              <a:t>package/source_notes/03.md resolves 03-c4 to segments yt-00022 through yt-00027.</a:t>
+              <a:t>editorial_review.md → config/editorial_policy.md → corrected October 10 rerun</a:t>
             </a:r>
             <a:endParaRPr lang="en-US" sz="1100" dirty="0"/>
           </a:p>
@@ -4861,9 +4899,9 @@
 </p:sld>
 </file>
 
-<file path=ppt/slides/slide8.xml><?xml version="1.0" encoding="utf-8"?>
+<file path=ppt/slides/slide7.xml><?xml version="1.0" encoding="utf-8"?>
 <p:sld xmlns:a="http://schemas.openxmlformats.org/drawingml/2006/main" xmlns:r="http://schemas.openxmlformats.org/officeDocument/2006/relationships" xmlns:p="http://schemas.openxmlformats.org/presentationml/2006/main">
-  <p:cSld name="Slide 8">
+  <p:cSld name="Slide 7">
     <p:bg>
       <p:bgPr>
         <a:solidFill>
@@ -4963,7 +5001,7 @@
                 <a:ea typeface="Arial" pitchFamily="34" charset="-122"/>
                 <a:cs typeface="Arial" pitchFamily="34" charset="-120"/>
               </a:rPr>
-              <a:t>REVIEW AND TRADEOFF</a:t>
+              <a:t>FAILURE RECOVERY</a:t>
             </a:r>
             <a:endParaRPr lang="en-US" sz="1100" dirty="0"/>
           </a:p>
@@ -5035,7 +5073,7 @@
                 <a:ea typeface="Arial" pitchFamily="34" charset="-122"/>
                 <a:cs typeface="Arial" pitchFamily="34" charset="-120"/>
               </a:rPr>
-              <a:t>HUMAN APPROVAL IS A STATE TRANSITION</a:t>
+              <a:t>PRESERVED FAILURE → EXPLICIT REPAIR</a:t>
             </a:r>
             <a:endParaRPr lang="en-US" sz="1100" dirty="0"/>
           </a:p>
@@ -5050,7 +5088,7 @@
         <p:spPr>
           <a:xfrm>
             <a:off x="533400" y="990302"/>
-            <a:ext cx="8238744" cy="383977"/>
+            <a:ext cx="8238744" cy="767953"/>
           </a:xfrm>
           <a:prstGeom prst="rect">
             <a:avLst/>
@@ -5080,7 +5118,7 @@
                 <a:ea typeface="Arial" pitchFamily="34" charset="-122"/>
                 <a:cs typeface="Arial" pitchFamily="34" charset="-120"/>
               </a:rPr>
-              <a:t>A changed artifact makes the old approval stale</a:t>
+              <a:t>The system records what broke and how the next run recovered</a:t>
             </a:r>
             <a:endParaRPr lang="en-US" sz="2800" dirty="0"/>
           </a:p>
@@ -5094,20 +5132,20 @@
         </p:nvSpPr>
         <p:spPr>
           <a:xfrm>
-            <a:off x="533400" y="1905000"/>
-            <a:ext cx="3835301" cy="2311301"/>
+            <a:off x="533400" y="1917650"/>
+            <a:ext cx="3810000" cy="2209800"/>
           </a:xfrm>
           <a:prstGeom prst="roundRect">
             <a:avLst>
-              <a:gd name="adj" fmla="val 1099"/>
+              <a:gd name="adj" fmla="val 1149"/>
             </a:avLst>
           </a:prstGeom>
           <a:solidFill>
-            <a:srgbClr val="FFFFFF"/>
+            <a:srgbClr val="F0E8DA"/>
           </a:solidFill>
           <a:ln w="9525">
             <a:solidFill>
-              <a:srgbClr val="CDD2D3"/>
+              <a:srgbClr val="F0E8DA"/>
             </a:solidFill>
           </a:ln>
         </p:spPr>
@@ -5130,8 +5168,8 @@
         </p:nvSpPr>
         <p:spPr>
           <a:xfrm>
-            <a:off x="822275" y="2168426"/>
-            <a:ext cx="3322701" cy="164902"/>
+            <a:off x="822275" y="2181076"/>
+            <a:ext cx="3296894" cy="164902"/>
           </a:xfrm>
           <a:prstGeom prst="rect">
             <a:avLst/>
@@ -5152,13 +5190,13 @@
             <a:r>
               <a:rPr lang="en-US" sz="1100" b="1" dirty="0">
                 <a:solidFill>
-                  <a:srgbClr val="2F6F72"/>
-                </a:solidFill>
-                <a:latin typeface="Arial" pitchFamily="34" charset="0"/>
-                <a:ea typeface="Arial" pitchFamily="34" charset="-122"/>
-                <a:cs typeface="Arial" pitchFamily="34" charset="-120"/>
-              </a:rPr>
-              <a:t>REVIEW FINGERPRINT</a:t>
+                  <a:srgbClr val="B58A45"/>
+                </a:solidFill>
+                <a:latin typeface="Arial" pitchFamily="34" charset="0"/>
+                <a:ea typeface="Arial" pitchFamily="34" charset="-122"/>
+                <a:cs typeface="Arial" pitchFamily="34" charset="-120"/>
+              </a:rPr>
+              <a:t>OCTOBER 9 FAILURE ARTIFACT</a:t>
             </a:r>
             <a:endParaRPr lang="en-US" sz="1100" dirty="0"/>
           </a:p>
@@ -5172,8 +5210,8 @@
         </p:nvSpPr>
         <p:spPr>
           <a:xfrm>
-            <a:off x="822275" y="2511028"/>
-            <a:ext cx="3322701" cy="269677"/>
+            <a:off x="822275" y="2523679"/>
+            <a:ext cx="3296894" cy="269677"/>
           </a:xfrm>
           <a:prstGeom prst="rect">
             <a:avLst/>
@@ -5203,7 +5241,7 @@
                 <a:ea typeface="Arial" pitchFamily="34" charset="-122"/>
                 <a:cs typeface="Arial" pitchFamily="34" charset="-120"/>
               </a:rPr>
-              <a:t>1361c8b…da4194a</a:t>
+              <a:t>Long audio + invalid 01-C1</a:t>
             </a:r>
             <a:endParaRPr lang="en-US" sz="1800" dirty="0"/>
           </a:p>
@@ -5217,8 +5255,8 @@
         </p:nvSpPr>
         <p:spPr>
           <a:xfrm>
-            <a:off x="822275" y="2933105"/>
-            <a:ext cx="3322701" cy="363141"/>
+            <a:off x="822275" y="2945755"/>
+            <a:ext cx="3296894" cy="363141"/>
           </a:xfrm>
           <a:prstGeom prst="rect">
             <a:avLst/>
@@ -5248,7 +5286,7 @@
                 <a:ea typeface="Arial" pitchFamily="34" charset="-122"/>
                 <a:cs typeface="Arial" pitchFamily="34" charset="-120"/>
               </a:rPr>
-              <a:t>Binds evidence, policy, prompts, articles, scripts, and deterministic checks.</a:t>
+              <a:t>Two podcasts exceeded the paid media limit. The brief schema rejected uppercase claim IDs.</a:t>
             </a:r>
             <a:endParaRPr lang="en-US" sz="1100" dirty="0"/>
           </a:p>
@@ -5262,90 +5300,12 @@
         </p:nvSpPr>
         <p:spPr>
           <a:xfrm>
-            <a:off x="822275" y="3473946"/>
-            <a:ext cx="3257550" cy="454521"/>
+            <a:off x="4800600" y="1917650"/>
+            <a:ext cx="3810000" cy="2209800"/>
           </a:xfrm>
           <a:prstGeom prst="roundRect">
             <a:avLst>
-              <a:gd name="adj" fmla="val 5588"/>
-            </a:avLst>
-          </a:prstGeom>
-          <a:solidFill>
-            <a:srgbClr val="E7EFEE"/>
-          </a:solidFill>
-          <a:ln w="9525">
-            <a:solidFill>
-              <a:srgbClr val="E7EFEE"/>
-            </a:solidFill>
-          </a:ln>
-        </p:spPr>
-        <p:txBody>
-          <a:bodyPr wrap="square" rtlCol="0" anchor="ctr"/>
-          <a:lstStyle/>
-          <a:p>
-            <a:pPr indent="0" marL="0">
-              <a:buNone/>
-            </a:pPr>
-            <a:endParaRPr lang="en-US" dirty="0"/>
-          </a:p>
-        </p:txBody>
-      </p:sp>
-      <p:sp>
-        <p:nvSpPr>
-          <p:cNvPr id="12" name="Text 10"/>
-          <p:cNvSpPr/>
-          <p:nvPr/>
-        </p:nvSpPr>
-        <p:spPr>
-          <a:xfrm>
-            <a:off x="984200" y="3610421"/>
-            <a:ext cx="2992374" cy="181570"/>
-          </a:xfrm>
-          <a:prstGeom prst="rect">
-            <a:avLst/>
-          </a:prstGeom>
-          <a:noFill/>
-          <a:ln/>
-        </p:spPr>
-        <p:txBody>
-          <a:bodyPr wrap="square" lIns="0" tIns="0" rIns="0" bIns="0" rtlCol="0" anchor="t"/>
-          <a:lstStyle/>
-          <a:p>
-            <a:pPr algn="l" indent="0" marL="0">
-              <a:lnSpc>
-                <a:spcPts val="1430"/>
-              </a:lnSpc>
-              <a:buNone/>
-            </a:pPr>
-            <a:r>
-              <a:rPr lang="en-US" sz="1100" b="1" dirty="0">
-                <a:solidFill>
-                  <a:srgbClr val="182433"/>
-                </a:solidFill>
-                <a:latin typeface="Arial" pitchFamily="34" charset="0"/>
-                <a:ea typeface="Arial" pitchFamily="34" charset="-122"/>
-                <a:cs typeface="Arial" pitchFamily="34" charset="-120"/>
-              </a:rPr>
-              <a:t>approval.json must name this exact value</a:t>
-            </a:r>
-            <a:endParaRPr lang="en-US" sz="1100" dirty="0"/>
-          </a:p>
-        </p:txBody>
-      </p:sp>
-      <p:sp>
-        <p:nvSpPr>
-          <p:cNvPr id="13" name="Text 11"/>
-          <p:cNvSpPr/>
-          <p:nvPr/>
-        </p:nvSpPr>
-        <p:spPr>
-          <a:xfrm>
-            <a:off x="4775299" y="1905000"/>
-            <a:ext cx="3835301" cy="2311301"/>
-          </a:xfrm>
-          <a:prstGeom prst="roundRect">
-            <a:avLst>
-              <a:gd name="adj" fmla="val 1099"/>
+              <a:gd name="adj" fmla="val 1149"/>
             </a:avLst>
           </a:prstGeom>
           <a:solidFill>
@@ -5370,14 +5330,14 @@
       </p:sp>
       <p:sp>
         <p:nvSpPr>
-          <p:cNvPr id="14" name="Text 12"/>
-          <p:cNvSpPr/>
-          <p:nvPr/>
-        </p:nvSpPr>
-        <p:spPr>
-          <a:xfrm>
-            <a:off x="5064175" y="2168426"/>
-            <a:ext cx="3322701" cy="164902"/>
+          <p:cNvPr id="12" name="Text 10"/>
+          <p:cNvSpPr/>
+          <p:nvPr/>
+        </p:nvSpPr>
+        <p:spPr>
+          <a:xfrm>
+            <a:off x="5089475" y="2181076"/>
+            <a:ext cx="3296894" cy="164902"/>
           </a:xfrm>
           <a:prstGeom prst="rect">
             <a:avLst/>
@@ -5404,7 +5364,7 @@
                 <a:ea typeface="Arial" pitchFamily="34" charset="-122"/>
                 <a:cs typeface="Arial" pitchFamily="34" charset="-120"/>
               </a:rPr>
-              <a:t>ARCHITECTURAL TRADEOFF</a:t>
+              <a:t>RECOVERED PATH</a:t>
             </a:r>
             <a:endParaRPr lang="en-US" sz="1100" dirty="0"/>
           </a:p>
@@ -5412,14 +5372,14 @@
       </p:sp>
       <p:sp>
         <p:nvSpPr>
-          <p:cNvPr id="15" name="Text 13"/>
-          <p:cNvSpPr/>
-          <p:nvPr/>
-        </p:nvSpPr>
-        <p:spPr>
-          <a:xfrm>
-            <a:off x="5064175" y="2511028"/>
-            <a:ext cx="3322701" cy="539353"/>
+          <p:cNvPr id="13" name="Text 11"/>
+          <p:cNvSpPr/>
+          <p:nvPr/>
+        </p:nvSpPr>
+        <p:spPr>
+          <a:xfrm>
+            <a:off x="5089475" y="2523679"/>
+            <a:ext cx="3296894" cy="269677"/>
           </a:xfrm>
           <a:prstGeom prst="rect">
             <a:avLst/>
@@ -5449,7 +5409,7 @@
                 <a:ea typeface="Arial" pitchFamily="34" charset="-122"/>
                 <a:cs typeface="Arial" pitchFamily="34" charset="-120"/>
               </a:rPr>
-              <a:t>Auditable process boundaries</a:t>
+              <a:t>MLX timestamps + strict retry</a:t>
             </a:r>
             <a:endParaRPr lang="en-US" sz="1800" dirty="0"/>
           </a:p>
@@ -5457,14 +5417,14 @@
       </p:sp>
       <p:sp>
         <p:nvSpPr>
-          <p:cNvPr id="16" name="Text 14"/>
-          <p:cNvSpPr/>
-          <p:nvPr/>
-        </p:nvSpPr>
-        <p:spPr>
-          <a:xfrm>
-            <a:off x="5064175" y="3202781"/>
-            <a:ext cx="3322701" cy="544711"/>
+          <p:cNvPr id="14" name="Text 12"/>
+          <p:cNvSpPr/>
+          <p:nvPr/>
+        </p:nvSpPr>
+        <p:spPr>
+          <a:xfrm>
+            <a:off x="5089475" y="2945755"/>
+            <a:ext cx="3296894" cy="363141"/>
           </a:xfrm>
           <a:prstGeom prst="rect">
             <a:avLst/>
@@ -5494,7 +5454,7 @@
                 <a:ea typeface="Arial" pitchFamily="34" charset="-122"/>
                 <a:cs typeface="Arial" pitchFamily="34" charset="-120"/>
               </a:rPr>
-              <a:t>Bash + JSONL improve replay and inspection. Pydantic, snapshots, receipts, and one store owner restore safety.</a:t>
+              <a:t>Local whisper-turbo handles long audio. Codex runs read-only. Final incremental API cost: $0.</a:t>
             </a:r>
             <a:endParaRPr lang="en-US" sz="1100" dirty="0"/>
           </a:p>
@@ -5502,7 +5462,7 @@
       </p:sp>
       <p:sp>
         <p:nvSpPr>
-          <p:cNvPr id="17" name="Text 15"/>
+          <p:cNvPr id="15" name="Text 13"/>
           <p:cNvSpPr/>
           <p:nvPr/>
         </p:nvSpPr>
@@ -5536,7 +5496,7 @@
                 <a:ea typeface="Arial" pitchFamily="34" charset="-122"/>
                 <a:cs typeface="Arial" pitchFamily="34" charset="-120"/>
               </a:rPr>
-              <a:t>The pipeline can request review. It cannot manufacture human consent.</a:t>
+              <a:t>The failed run remains intact; the successful run does not rewrite its history.</a:t>
             </a:r>
             <a:endParaRPr lang="en-US" sz="1100" dirty="0"/>
           </a:p>

</xml_diff>